<commit_message>
Update project team details and test counts in README, PDFs, and PPTX
</commit_message>
<xml_diff>
--- a/ControlPlane_Business_Proposal.pptx
+++ b/ControlPlane_Business_Proposal.pptx
@@ -10,6 +10,7 @@
     <p:sldId id="258" r:id="rId9"/>
     <p:sldId id="259" r:id="rId10"/>
     <p:sldId id="260" r:id="rId11"/>
+    <p:sldId id="261" r:id="rId12"/>
   </p:sldIdLst>
   <p:sldSz cx="12191695" cy="6858000" type="screen4x3"/>
   <p:notesSz cx="6858000" cy="9144000"/>
@@ -4236,7 +4237,7 @@
               </a:defRPr>
             </a:pPr>
             <a:r>
-              <a:t>145 / 145</a:t>
+              <a:t>169 / 169</a:t>
             </a:r>
           </a:p>
           <a:p>
@@ -4963,6 +4964,434 @@
             </a:pPr>
             <a:r>
               <a:t>• Key Cost Drivers: Low infrastructure overhead due to lightweight Tier 0 pre-filtering.</a:t>
+            </a:r>
+          </a:p>
+        </p:txBody>
+      </p:sp>
+    </p:spTree>
+  </p:cSld>
+  <p:clrMapOvr>
+    <a:masterClrMapping/>
+  </p:clrMapOvr>
+</p:sld>
+</file>
+
+<file path=ppt/slides/slide6.xml><?xml version="1.0" encoding="utf-8"?>
+<p:sld xmlns:a="http://schemas.openxmlformats.org/drawingml/2006/main" xmlns:p="http://schemas.openxmlformats.org/presentationml/2006/main" xmlns:r="http://schemas.openxmlformats.org/officeDocument/2006/relationships">
+  <p:cSld>
+    <p:bg>
+      <p:bgPr>
+        <a:solidFill>
+          <a:srgbClr val="F8FAFC"/>
+        </a:solidFill>
+        <a:effectLst/>
+      </p:bgPr>
+    </p:bg>
+    <p:spTree>
+      <p:nvGrpSpPr>
+        <p:cNvPr id="1" name=""/>
+        <p:cNvGrpSpPr/>
+        <p:nvPr/>
+      </p:nvGrpSpPr>
+      <p:grpSpPr/>
+      <p:sp>
+        <p:nvSpPr>
+          <p:cNvPr id="2" name="TextBox 1"/>
+          <p:cNvSpPr txBox="1"/>
+          <p:nvPr/>
+        </p:nvSpPr>
+        <p:spPr>
+          <a:xfrm>
+            <a:off x="731520" y="365760"/>
+            <a:ext cx="10058400" cy="365760"/>
+          </a:xfrm>
+          <a:prstGeom prst="rect">
+            <a:avLst/>
+          </a:prstGeom>
+          <a:noFill/>
+        </p:spPr>
+        <p:txBody>
+          <a:bodyPr wrap="square">
+            <a:spAutoFit/>
+          </a:bodyPr>
+          <a:lstStyle/>
+          <a:p>
+            <a:pPr>
+              <a:defRPr sz="1000" b="1">
+                <a:solidFill>
+                  <a:srgbClr val="7C3AED"/>
+                </a:solidFill>
+                <a:latin typeface="Calibri"/>
+              </a:defRPr>
+            </a:pPr>
+            <a:r>
+              <a:t>ACCENTURE INNOVATION CHALLENGE 2026</a:t>
+            </a:r>
+          </a:p>
+        </p:txBody>
+      </p:sp>
+      <p:sp>
+        <p:nvSpPr>
+          <p:cNvPr id="3" name="TextBox 2"/>
+          <p:cNvSpPr txBox="1"/>
+          <p:nvPr/>
+        </p:nvSpPr>
+        <p:spPr>
+          <a:xfrm>
+            <a:off x="731520" y="640080"/>
+            <a:ext cx="10515600" cy="640080"/>
+          </a:xfrm>
+          <a:prstGeom prst="rect">
+            <a:avLst/>
+          </a:prstGeom>
+          <a:noFill/>
+        </p:spPr>
+        <p:txBody>
+          <a:bodyPr wrap="square">
+            <a:spAutoFit/>
+          </a:bodyPr>
+          <a:lstStyle/>
+          <a:p>
+            <a:pPr>
+              <a:defRPr sz="2400" b="1">
+                <a:solidFill>
+                  <a:srgbClr val="1E293B"/>
+                </a:solidFill>
+                <a:latin typeface="Calibri"/>
+              </a:defRPr>
+            </a:pPr>
+            <a:r>
+              <a:t>Project Team &amp; Contributors</a:t>
+            </a:r>
+          </a:p>
+        </p:txBody>
+      </p:sp>
+      <p:sp>
+        <p:nvSpPr>
+          <p:cNvPr id="4" name="Rounded Rectangle 3"/>
+          <p:cNvSpPr/>
+          <p:nvPr/>
+        </p:nvSpPr>
+        <p:spPr>
+          <a:xfrm>
+            <a:off x="731520" y="1645920"/>
+            <a:ext cx="3383280" cy="4754880"/>
+          </a:xfrm>
+          <a:prstGeom prst="roundRect">
+            <a:avLst/>
+          </a:prstGeom>
+          <a:solidFill>
+            <a:srgbClr val="FFFFFF"/>
+          </a:solidFill>
+          <a:ln w="12700">
+            <a:solidFill>
+              <a:srgbClr val="E2E8F0"/>
+            </a:solidFill>
+          </a:ln>
+        </p:spPr>
+        <p:style>
+          <a:lnRef idx="1">
+            <a:schemeClr val="accent1"/>
+          </a:lnRef>
+          <a:fillRef idx="3">
+            <a:schemeClr val="accent1"/>
+          </a:fillRef>
+          <a:effectRef idx="2">
+            <a:schemeClr val="accent1"/>
+          </a:effectRef>
+          <a:fontRef idx="minor">
+            <a:schemeClr val="lt1"/>
+          </a:fontRef>
+        </p:style>
+        <p:txBody>
+          <a:bodyPr rtlCol="0" anchor="ctr"/>
+          <a:lstStyle/>
+          <a:p>
+            <a:pPr algn="ctr"/>
+          </a:p>
+        </p:txBody>
+      </p:sp>
+      <p:sp>
+        <p:nvSpPr>
+          <p:cNvPr id="5" name="TextBox 4"/>
+          <p:cNvSpPr txBox="1"/>
+          <p:nvPr/>
+        </p:nvSpPr>
+        <p:spPr>
+          <a:xfrm>
+            <a:off x="914400" y="1828800"/>
+            <a:ext cx="3017520" cy="4389120"/>
+          </a:xfrm>
+          <a:prstGeom prst="rect">
+            <a:avLst/>
+          </a:prstGeom>
+          <a:noFill/>
+        </p:spPr>
+        <p:txBody>
+          <a:bodyPr wrap="square">
+            <a:spAutoFit/>
+          </a:bodyPr>
+          <a:lstStyle/>
+          <a:p>
+            <a:pPr>
+              <a:defRPr sz="1800" b="1">
+                <a:solidFill>
+                  <a:srgbClr val="7C3AED"/>
+                </a:solidFill>
+              </a:defRPr>
+            </a:pPr>
+            <a:r>
+              <a:t>Mohith Chandra</a:t>
+            </a:r>
+          </a:p>
+          <a:p>
+            <a:pPr>
+              <a:spcBef>
+                <a:spcPts val="800"/>
+              </a:spcBef>
+              <a:defRPr sz="1300" b="1">
+                <a:solidFill>
+                  <a:srgbClr val="1E293B"/>
+                </a:solidFill>
+              </a:defRPr>
+            </a:pPr>
+            <a:r>
+              <a:t>Team Lead &amp; Core Engineer</a:t>
+            </a:r>
+          </a:p>
+          <a:p>
+            <a:pPr>
+              <a:spcBef>
+                <a:spcPts val="1200"/>
+              </a:spcBef>
+              <a:defRPr sz="1100">
+                <a:solidFill>
+                  <a:srgbClr val="64748B"/>
+                </a:solidFill>
+              </a:defRPr>
+            </a:pPr>
+            <a:r>
+              <a:t>Designed overall architecture, built inline gateway proxy, dynamic risk control interface, and cryptographic ledger.</a:t>
+            </a:r>
+          </a:p>
+        </p:txBody>
+      </p:sp>
+      <p:sp>
+        <p:nvSpPr>
+          <p:cNvPr id="6" name="Rounded Rectangle 5"/>
+          <p:cNvSpPr/>
+          <p:nvPr/>
+        </p:nvSpPr>
+        <p:spPr>
+          <a:xfrm>
+            <a:off x="4389120" y="1645920"/>
+            <a:ext cx="3383280" cy="4754880"/>
+          </a:xfrm>
+          <a:prstGeom prst="roundRect">
+            <a:avLst/>
+          </a:prstGeom>
+          <a:solidFill>
+            <a:srgbClr val="FFFFFF"/>
+          </a:solidFill>
+          <a:ln w="12700">
+            <a:solidFill>
+              <a:srgbClr val="E2E8F0"/>
+            </a:solidFill>
+          </a:ln>
+        </p:spPr>
+        <p:style>
+          <a:lnRef idx="1">
+            <a:schemeClr val="accent1"/>
+          </a:lnRef>
+          <a:fillRef idx="3">
+            <a:schemeClr val="accent1"/>
+          </a:fillRef>
+          <a:effectRef idx="2">
+            <a:schemeClr val="accent1"/>
+          </a:effectRef>
+          <a:fontRef idx="minor">
+            <a:schemeClr val="lt1"/>
+          </a:fontRef>
+        </p:style>
+        <p:txBody>
+          <a:bodyPr rtlCol="0" anchor="ctr"/>
+          <a:lstStyle/>
+          <a:p>
+            <a:pPr algn="ctr"/>
+          </a:p>
+        </p:txBody>
+      </p:sp>
+      <p:sp>
+        <p:nvSpPr>
+          <p:cNvPr id="7" name="TextBox 6"/>
+          <p:cNvSpPr txBox="1"/>
+          <p:nvPr/>
+        </p:nvSpPr>
+        <p:spPr>
+          <a:xfrm>
+            <a:off x="4572000" y="1828800"/>
+            <a:ext cx="3017520" cy="4389120"/>
+          </a:xfrm>
+          <a:prstGeom prst="rect">
+            <a:avLst/>
+          </a:prstGeom>
+          <a:noFill/>
+        </p:spPr>
+        <p:txBody>
+          <a:bodyPr wrap="square">
+            <a:spAutoFit/>
+          </a:bodyPr>
+          <a:lstStyle/>
+          <a:p>
+            <a:pPr>
+              <a:defRPr sz="1800" b="1">
+                <a:solidFill>
+                  <a:srgbClr val="0EA5E9"/>
+                </a:solidFill>
+              </a:defRPr>
+            </a:pPr>
+            <a:r>
+              <a:t>Monal Gupta</a:t>
+            </a:r>
+          </a:p>
+          <a:p>
+            <a:pPr>
+              <a:spcBef>
+                <a:spcPts val="800"/>
+              </a:spcBef>
+              <a:defRPr sz="1300" b="1">
+                <a:solidFill>
+                  <a:srgbClr val="1E293B"/>
+                </a:solidFill>
+              </a:defRPr>
+            </a:pPr>
+            <a:r>
+              <a:t>Core NLP &amp; Fullstack Developer</a:t>
+            </a:r>
+          </a:p>
+          <a:p>
+            <a:pPr>
+              <a:spcBef>
+                <a:spcPts val="1200"/>
+              </a:spcBef>
+              <a:defRPr sz="1100">
+                <a:solidFill>
+                  <a:srgbClr val="64748B"/>
+                </a:solidFill>
+              </a:defRPr>
+            </a:pPr>
+            <a:r>
+              <a:t>Implemented claim verification algorithms, PII scanner, React control console, and email notification integrations.</a:t>
+            </a:r>
+          </a:p>
+        </p:txBody>
+      </p:sp>
+      <p:sp>
+        <p:nvSpPr>
+          <p:cNvPr id="8" name="Rounded Rectangle 7"/>
+          <p:cNvSpPr/>
+          <p:nvPr/>
+        </p:nvSpPr>
+        <p:spPr>
+          <a:xfrm>
+            <a:off x="8046720" y="1645920"/>
+            <a:ext cx="3383280" cy="4754880"/>
+          </a:xfrm>
+          <a:prstGeom prst="roundRect">
+            <a:avLst/>
+          </a:prstGeom>
+          <a:solidFill>
+            <a:srgbClr val="FFFFFF"/>
+          </a:solidFill>
+          <a:ln w="12700">
+            <a:solidFill>
+              <a:srgbClr val="E2E8F0"/>
+            </a:solidFill>
+          </a:ln>
+        </p:spPr>
+        <p:style>
+          <a:lnRef idx="1">
+            <a:schemeClr val="accent1"/>
+          </a:lnRef>
+          <a:fillRef idx="3">
+            <a:schemeClr val="accent1"/>
+          </a:fillRef>
+          <a:effectRef idx="2">
+            <a:schemeClr val="accent1"/>
+          </a:effectRef>
+          <a:fontRef idx="minor">
+            <a:schemeClr val="lt1"/>
+          </a:fontRef>
+        </p:style>
+        <p:txBody>
+          <a:bodyPr rtlCol="0" anchor="ctr"/>
+          <a:lstStyle/>
+          <a:p>
+            <a:pPr algn="ctr"/>
+          </a:p>
+        </p:txBody>
+      </p:sp>
+      <p:sp>
+        <p:nvSpPr>
+          <p:cNvPr id="9" name="TextBox 8"/>
+          <p:cNvSpPr txBox="1"/>
+          <p:nvPr/>
+        </p:nvSpPr>
+        <p:spPr>
+          <a:xfrm>
+            <a:off x="8229600" y="1828800"/>
+            <a:ext cx="3017520" cy="4389120"/>
+          </a:xfrm>
+          <a:prstGeom prst="rect">
+            <a:avLst/>
+          </a:prstGeom>
+          <a:noFill/>
+        </p:spPr>
+        <p:txBody>
+          <a:bodyPr wrap="square">
+            <a:spAutoFit/>
+          </a:bodyPr>
+          <a:lstStyle/>
+          <a:p>
+            <a:pPr>
+              <a:defRPr sz="1800" b="1">
+                <a:solidFill>
+                  <a:srgbClr val="7C3AED"/>
+                </a:solidFill>
+              </a:defRPr>
+            </a:pPr>
+            <a:r>
+              <a:t>Veda Vikas</a:t>
+            </a:r>
+          </a:p>
+          <a:p>
+            <a:pPr>
+              <a:spcBef>
+                <a:spcPts val="800"/>
+              </a:spcBef>
+              <a:defRPr sz="1300" b="1">
+                <a:solidFill>
+                  <a:srgbClr val="1E293B"/>
+                </a:solidFill>
+              </a:defRPr>
+            </a:pPr>
+            <a:r>
+              <a:t>System Architect &amp; Developer</a:t>
+            </a:r>
+          </a:p>
+          <a:p>
+            <a:pPr>
+              <a:spcBef>
+                <a:spcPts val="1200"/>
+              </a:spcBef>
+              <a:defRPr sz="1100">
+                <a:solidFill>
+                  <a:srgbClr val="64748B"/>
+                </a:solidFill>
+              </a:defRPr>
+            </a:pPr>
+            <a:r>
+              <a:t>Designed database schema, tool-call gating mechanism, policy loading engines, and automated test suite.</a:t>
             </a:r>
           </a:p>
         </p:txBody>

</xml_diff>